<commit_message>
Slides: no em dash on sd-06-015 slide 3, re-export PPTX
Co-Authored-By: Claude Opus 5.5 <noreply@anthropic.com>
Claude-Session: https://claude.ai/code/session_01C9pH8NnezrynRr5dznPeP3
</commit_message>
<xml_diff>
--- a/system-design-101/vi/lessons/sd-06-015/slides/sd-06-015.pptx
+++ b/system-design-101/vi/lessons/sd-06-015/slides/sd-06-015.pptx
@@ -6255,7 +6255,7 @@
               <a:buNone/>
             </a:pPr>
             <a:r>
-              <a:rPr lang="en-US" sz="2250" dirty="0" spc="3" kern="0">
+              <a:rPr lang="en-US" sz="2250" dirty="0" spc="1" kern="0">
                 <a:solidFill>
                   <a:srgbClr val="6B6A66"/>
                 </a:solidFill>
@@ -6263,7 +6263,40 @@
                 <a:ea typeface="Be Vietnam Pro" pitchFamily="34" charset="-122"/>
                 <a:cs typeface="Be Vietnam Pro" pitchFamily="34" charset="-120"/>
               </a:rPr>
-              <a:t>—</a:t>
+              <a:t>Không</a:t>
+            </a:r>
+            <a:r>
+              <a:rPr lang="en-US" sz="2250" dirty="0" spc="5" kern="0">
+                <a:solidFill>
+                  <a:srgbClr val="6B6A66"/>
+                </a:solidFill>
+                <a:latin typeface="Be Vietnam Pro" pitchFamily="34" charset="0"/>
+                <a:ea typeface="Be Vietnam Pro" pitchFamily="34" charset="-122"/>
+                <a:cs typeface="Be Vietnam Pro" pitchFamily="34" charset="-120"/>
+              </a:rPr>
+              <a:t> có</a:t>
+            </a:r>
+            <a:r>
+              <a:rPr lang="en-US" sz="2250" dirty="0" spc="-2" kern="0">
+                <a:solidFill>
+                  <a:srgbClr val="6B6A66"/>
+                </a:solidFill>
+                <a:latin typeface="Be Vietnam Pro" pitchFamily="34" charset="0"/>
+                <a:ea typeface="Be Vietnam Pro" pitchFamily="34" charset="-122"/>
+                <a:cs typeface="Be Vietnam Pro" pitchFamily="34" charset="-120"/>
+              </a:rPr>
+              <a:t> kiểu</a:t>
+            </a:r>
+            <a:r>
+              <a:rPr lang="en-US" sz="2250" dirty="0" spc="-1" kern="0">
+                <a:solidFill>
+                  <a:srgbClr val="6B6A66"/>
+                </a:solidFill>
+                <a:latin typeface="Be Vietnam Pro" pitchFamily="34" charset="0"/>
+                <a:ea typeface="Be Vietnam Pro" pitchFamily="34" charset="-122"/>
+                <a:cs typeface="Be Vietnam Pro" pitchFamily="34" charset="-120"/>
+              </a:rPr>
+              <a:t> nào</a:t>
             </a:r>
             <a:endParaRPr lang="en-US" sz="2250" dirty="0"/>
           </a:p>

</xml_diff>